<commit_message>
refactor: enforce 100% pure MIT 6.006 SOT and remove external references
</commit_message>
<xml_diff>
--- a/static/Dijkstra_Algorithm_Complete_Guide.pptx
+++ b/static/Dijkstra_Algorithm_Complete_Guide.pptx
@@ -5351,7 +5351,7 @@
               </a:defRPr>
             </a:pPr>
             <a:r>
-              <a:t>Simplicity and Optimality for Dense Graphs (GeeksforGeeks)</a:t>
+              <a:t>Simplicity and Optimality for Dense Graphs (MIT 6.006 (Prof. Erik Demaine &amp; Srinivas Devadas))</a:t>
             </a:r>
           </a:p>
         </p:txBody>
@@ -5880,7 +5880,7 @@
               </a:defRPr>
             </a:pPr>
             <a:r>
-              <a:t>The Production Standard for Sparse Networks (GeeksforGeeks)</a:t>
+              <a:t>The Production Standard for Sparse Networks (MIT 6.006 (Prof. Erik Demaine &amp; Srinivas Devadas))</a:t>
             </a:r>
           </a:p>
         </p:txBody>
@@ -8144,7 +8144,7 @@
               </a:defRPr>
             </a:pPr>
             <a:r>
-              <a:t>Authentic study archive curated from GeeksforGeeks and MIT 6.006 (Demaine &amp; Devadas), split into semantic code &amp; math chunks.</a:t>
+              <a:t>Authentic study archive curated from MIT 6.006 (Demaine &amp; Devadas), split into semantic code &amp; math chunks.</a:t>
             </a:r>
           </a:p>
         </p:txBody>

</xml_diff>